<commit_message>
Enlarge report screenshots and highlight applicant and admin actions
</commit_message>
<xml_diff>
--- a/preview/reports/permit/report.pptx
+++ b/preview/reports/permit/report.pptx
@@ -8424,7 +8424,7 @@
               </a:defRPr>
             </a:pPr>
             <a:r>
-              <a:t>실제 신청·관리자 화면과 이용 흐름</a:t>
+              <a:t>신청·관리자 화면, 핵심 기능을 확대해서 보기</a:t>
             </a:r>
           </a:p>
         </p:txBody>
@@ -8463,7 +8463,7 @@
               </a:defRPr>
             </a:pPr>
             <a:r>
-              <a:t>제공해주신 운영 화면을 기준으로 기능과 처리 순서를 정리했습니다.</a:t>
+              <a:t>입력 영역과 관리자 처리 메뉴를 확대하고, 주요 조작 위치를 진한 녹색으로 강조했습니다.</a:t>
             </a:r>
           </a:p>
         </p:txBody>
@@ -8549,7 +8549,7 @@
               </a:defRPr>
             </a:pPr>
             <a:r>
-              <a:t>화면 및 활용</a:t>
+              <a:t>핵심 화면 확대</a:t>
             </a:r>
           </a:p>
         </p:txBody>
@@ -8640,8 +8640,8 @@
         </p:nvSpPr>
         <p:spPr>
           <a:xfrm>
-            <a:off x="487680" y="1447800"/>
-            <a:ext cx="5516880" cy="4328160"/>
+            <a:off x="487680" y="1386840"/>
+            <a:ext cx="11216640" cy="2103120"/>
           </a:xfrm>
           <a:prstGeom prst="roundRect">
             <a:avLst>
@@ -8681,14 +8681,281 @@
       </p:sp>
       <p:sp>
         <p:nvSpPr>
-          <p:cNvPr id="10" name="Rounded Rectangle 9"/>
+          <p:cNvPr id="10" name="TextBox 9"/>
+          <p:cNvSpPr txBox="1"/>
+          <p:nvPr/>
+        </p:nvSpPr>
+        <p:spPr>
+          <a:xfrm>
+            <a:off x="655320" y="1516380"/>
+            <a:ext cx="7985759" cy="304800"/>
+          </a:xfrm>
+          <a:prstGeom prst="rect">
+            <a:avLst/>
+          </a:prstGeom>
+          <a:noFill/>
+        </p:spPr>
+        <p:txBody>
+          <a:bodyPr wrap="square" lIns="0" rIns="0" tIns="0" bIns="0">
+            <a:spAutoFit/>
+          </a:bodyPr>
+          <a:lstStyle/>
+          <a:p>
+            <a:pPr>
+              <a:spcAft>
+                <a:spcPts val="560"/>
+              </a:spcAft>
+              <a:defRPr sz="1680" b="1">
+                <a:solidFill>
+                  <a:srgbClr val="17684F"/>
+                </a:solidFill>
+                <a:latin typeface="Noto Sans CJK KR"/>
+              </a:defRPr>
+            </a:pPr>
+            <a:r>
+              <a:t>01  신청자 | 방문자별 정보 입력 후 신청</a:t>
+            </a:r>
+          </a:p>
+        </p:txBody>
+      </p:sp>
+      <p:pic>
+        <p:nvPicPr>
+          <p:cNvPr id="11" name="Picture 10" descr="report-applicant-focus.png"/>
+          <p:cNvPicPr>
+            <a:picLocks noChangeAspect="1"/>
+          </p:cNvPicPr>
+          <p:nvPr/>
+        </p:nvPicPr>
+        <p:blipFill>
+          <a:blip r:embed="rId2"/>
+          <a:stretch>
+            <a:fillRect/>
+          </a:stretch>
+        </p:blipFill>
+        <p:spPr>
+          <a:xfrm>
+            <a:off x="662940" y="1960583"/>
+            <a:ext cx="8031480" cy="986113"/>
+          </a:xfrm>
+          <a:prstGeom prst="rect">
+            <a:avLst/>
+          </a:prstGeom>
+        </p:spPr>
+      </p:pic>
+      <p:sp>
+        <p:nvSpPr>
+          <p:cNvPr id="12" name="TextBox 11"/>
+          <p:cNvSpPr txBox="1"/>
+          <p:nvPr/>
+        </p:nvSpPr>
+        <p:spPr>
+          <a:xfrm>
+            <a:off x="685800" y="3101340"/>
+            <a:ext cx="7940040" cy="236220"/>
+          </a:xfrm>
+          <a:prstGeom prst="rect">
+            <a:avLst/>
+          </a:prstGeom>
+          <a:noFill/>
+        </p:spPr>
+        <p:txBody>
+          <a:bodyPr wrap="square" lIns="0" rIns="0" tIns="0" bIns="0">
+            <a:spAutoFit/>
+          </a:bodyPr>
+          <a:lstStyle/>
+          <a:p>
+            <a:pPr>
+              <a:spcAft>
+                <a:spcPts val="440"/>
+              </a:spcAft>
+              <a:defRPr sz="1320" b="1">
+                <a:solidFill>
+                  <a:srgbClr val="193B30"/>
+                </a:solidFill>
+                <a:latin typeface="Noto Sans CJK KR"/>
+              </a:defRPr>
+            </a:pPr>
+            <a:r>
+              <a:t>방문일자·목적·요청팀·출입위치·연락처를 방문자마다 개별 입력</a:t>
+            </a:r>
+          </a:p>
+        </p:txBody>
+      </p:sp>
+      <p:sp>
+        <p:nvSpPr>
+          <p:cNvPr id="13" name="Rounded Rectangle 12"/>
           <p:cNvSpPr/>
           <p:nvPr/>
         </p:nvSpPr>
         <p:spPr>
           <a:xfrm>
-            <a:off x="6187440" y="1447800"/>
-            <a:ext cx="5516880" cy="4328160"/>
+            <a:off x="8869680" y="1554480"/>
+            <a:ext cx="2651760" cy="1752600"/>
+          </a:xfrm>
+          <a:prstGeom prst="roundRect">
+            <a:avLst>
+              <a:gd name="adj" fmla="val 12000"/>
+            </a:avLst>
+          </a:prstGeom>
+          <a:solidFill>
+            <a:srgbClr val="EAF4EE"/>
+          </a:solidFill>
+          <a:ln w="12700">
+            <a:solidFill>
+              <a:srgbClr val="D5E4DD"/>
+            </a:solidFill>
+          </a:ln>
+        </p:spPr>
+        <p:style>
+          <a:lnRef idx="1">
+            <a:schemeClr val="accent1"/>
+          </a:lnRef>
+          <a:fillRef idx="3">
+            <a:schemeClr val="accent1"/>
+          </a:fillRef>
+          <a:effectRef idx="2">
+            <a:schemeClr val="accent1"/>
+          </a:effectRef>
+          <a:fontRef idx="minor">
+            <a:schemeClr val="lt1"/>
+          </a:fontRef>
+        </p:style>
+        <p:txBody>
+          <a:bodyPr rtlCol="0" anchor="ctr"/>
+          <a:lstStyle/>
+          <a:p>
+            <a:pPr algn="ctr"/>
+          </a:p>
+        </p:txBody>
+      </p:sp>
+      <p:sp>
+        <p:nvSpPr>
+          <p:cNvPr id="14" name="TextBox 13"/>
+          <p:cNvSpPr txBox="1"/>
+          <p:nvPr/>
+        </p:nvSpPr>
+        <p:spPr>
+          <a:xfrm>
+            <a:off x="9006840" y="1676400"/>
+            <a:ext cx="2362200" cy="266700"/>
+          </a:xfrm>
+          <a:prstGeom prst="rect">
+            <a:avLst/>
+          </a:prstGeom>
+          <a:noFill/>
+        </p:spPr>
+        <p:txBody>
+          <a:bodyPr wrap="square" lIns="0" rIns="0" tIns="0" bIns="0">
+            <a:spAutoFit/>
+          </a:bodyPr>
+          <a:lstStyle/>
+          <a:p>
+            <a:pPr>
+              <a:spcAft>
+                <a:spcPts val="520"/>
+              </a:spcAft>
+              <a:defRPr sz="1560" b="1">
+                <a:solidFill>
+                  <a:srgbClr val="17684F"/>
+                </a:solidFill>
+                <a:latin typeface="Noto Sans CJK KR"/>
+              </a:defRPr>
+            </a:pPr>
+            <a:r>
+              <a:t>입력 → 확인 → 신청</a:t>
+            </a:r>
+          </a:p>
+        </p:txBody>
+      </p:sp>
+      <p:sp>
+        <p:nvSpPr>
+          <p:cNvPr id="15" name="TextBox 14"/>
+          <p:cNvSpPr txBox="1"/>
+          <p:nvPr/>
+        </p:nvSpPr>
+        <p:spPr>
+          <a:xfrm>
+            <a:off x="9006840" y="2026920"/>
+            <a:ext cx="2324100" cy="571500"/>
+          </a:xfrm>
+          <a:prstGeom prst="rect">
+            <a:avLst/>
+          </a:prstGeom>
+          <a:noFill/>
+        </p:spPr>
+        <p:txBody>
+          <a:bodyPr wrap="square" lIns="0" rIns="0" tIns="0" bIns="0">
+            <a:spAutoFit/>
+          </a:bodyPr>
+          <a:lstStyle/>
+          <a:p>
+            <a:pPr>
+              <a:spcAft>
+                <a:spcPts val="440"/>
+              </a:spcAft>
+              <a:defRPr sz="1320" b="0">
+                <a:solidFill>
+                  <a:srgbClr val="35464C"/>
+                </a:solidFill>
+                <a:latin typeface="Noto Sans CJK KR"/>
+              </a:defRPr>
+            </a:pPr>
+            <a:r>
+              <a:t>누락·형식 오류 안내</a:t>
+            </a:r>
+          </a:p>
+          <a:p>
+            <a:pPr>
+              <a:spcAft>
+                <a:spcPts val="440"/>
+              </a:spcAft>
+              <a:defRPr sz="1320" b="0">
+                <a:solidFill>
+                  <a:srgbClr val="35464C"/>
+                </a:solidFill>
+                <a:latin typeface="Noto Sans CJK KR"/>
+              </a:defRPr>
+            </a:pPr>
+            <a:r>
+              <a:t>이 탭에 자동 임시저장</a:t>
+            </a:r>
+          </a:p>
+        </p:txBody>
+      </p:sp>
+      <p:pic>
+        <p:nvPicPr>
+          <p:cNvPr id="16" name="Picture 15" descr="report-submit-focus.png"/>
+          <p:cNvPicPr>
+            <a:picLocks noChangeAspect="1"/>
+          </p:cNvPicPr>
+          <p:nvPr/>
+        </p:nvPicPr>
+        <p:blipFill>
+          <a:blip r:embed="rId3"/>
+          <a:stretch>
+            <a:fillRect/>
+          </a:stretch>
+        </p:blipFill>
+        <p:spPr>
+          <a:xfrm>
+            <a:off x="9361040" y="2712720"/>
+            <a:ext cx="1653798" cy="495299"/>
+          </a:xfrm>
+          <a:prstGeom prst="rect">
+            <a:avLst/>
+          </a:prstGeom>
+        </p:spPr>
+      </p:pic>
+      <p:sp>
+        <p:nvSpPr>
+          <p:cNvPr id="17" name="Rounded Rectangle 16"/>
+          <p:cNvSpPr/>
+          <p:nvPr/>
+        </p:nvSpPr>
+        <p:spPr>
+          <a:xfrm>
+            <a:off x="487680" y="3657600"/>
+            <a:ext cx="11216640" cy="2118360"/>
           </a:xfrm>
           <a:prstGeom prst="roundRect">
             <a:avLst>
@@ -8728,14 +8995,14 @@
       </p:sp>
       <p:sp>
         <p:nvSpPr>
-          <p:cNvPr id="11" name="TextBox 10"/>
+          <p:cNvPr id="18" name="TextBox 17"/>
           <p:cNvSpPr txBox="1"/>
           <p:nvPr/>
         </p:nvSpPr>
         <p:spPr>
           <a:xfrm>
-            <a:off x="670560" y="1615440"/>
-            <a:ext cx="5135880" cy="320040"/>
+            <a:off x="655320" y="3787140"/>
+            <a:ext cx="7985759" cy="304800"/>
           </a:xfrm>
           <a:prstGeom prst="rect">
             <a:avLst/>
@@ -8760,108 +9027,45 @@
               </a:defRPr>
             </a:pPr>
             <a:r>
-              <a:t>신청자 | 방문자 정보 입력·신청</a:t>
-            </a:r>
-          </a:p>
-        </p:txBody>
-      </p:sp>
-      <p:sp>
-        <p:nvSpPr>
-          <p:cNvPr id="12" name="TextBox 11"/>
-          <p:cNvSpPr txBox="1"/>
-          <p:nvPr/>
-        </p:nvSpPr>
-        <p:spPr>
-          <a:xfrm>
-            <a:off x="6370320" y="1615440"/>
-            <a:ext cx="5135880" cy="320040"/>
-          </a:xfrm>
-          <a:prstGeom prst="rect">
-            <a:avLst/>
-          </a:prstGeom>
-          <a:noFill/>
-        </p:spPr>
-        <p:txBody>
-          <a:bodyPr wrap="square" lIns="0" rIns="0" tIns="0" bIns="0">
-            <a:spAutoFit/>
-          </a:bodyPr>
-          <a:lstStyle/>
-          <a:p>
-            <a:pPr>
-              <a:spcAft>
-                <a:spcPts val="560"/>
-              </a:spcAft>
-              <a:defRPr sz="1680" b="1">
-                <a:solidFill>
-                  <a:srgbClr val="17684F"/>
-                </a:solidFill>
-                <a:latin typeface="Noto Sans CJK KR"/>
-              </a:defRPr>
-            </a:pPr>
-            <a:r>
-              <a:t>관리자 | 확인·제출·승인·삭제</a:t>
+              <a:t>02  관리자 | 선택한 신청을 한 번에 처리</a:t>
             </a:r>
           </a:p>
         </p:txBody>
       </p:sp>
       <p:pic>
         <p:nvPicPr>
-          <p:cNvPr id="13" name="Picture 12" descr="report-applicant.png"/>
+          <p:cNvPr id="19" name="Picture 18" descr="report-admin-focus.png"/>
           <p:cNvPicPr>
             <a:picLocks noChangeAspect="1"/>
           </p:cNvPicPr>
           <p:nvPr/>
         </p:nvPicPr>
         <p:blipFill>
-          <a:blip r:embed="rId2"/>
+          <a:blip r:embed="rId4"/>
           <a:stretch>
             <a:fillRect/>
           </a:stretch>
         </p:blipFill>
         <p:spPr>
           <a:xfrm>
-            <a:off x="624840" y="2197406"/>
-            <a:ext cx="5242560" cy="1800246"/>
+            <a:off x="662940" y="4170586"/>
+            <a:ext cx="8031480" cy="1176207"/>
           </a:xfrm>
           <a:prstGeom prst="rect">
             <a:avLst/>
           </a:prstGeom>
         </p:spPr>
       </p:pic>
-      <p:pic>
-        <p:nvPicPr>
-          <p:cNvPr id="14" name="Picture 13" descr="report-admin.png"/>
-          <p:cNvPicPr>
-            <a:picLocks noChangeAspect="1"/>
-          </p:cNvPicPr>
-          <p:nvPr/>
-        </p:nvPicPr>
-        <p:blipFill>
-          <a:blip r:embed="rId3"/>
-          <a:stretch>
-            <a:fillRect/>
-          </a:stretch>
-        </p:blipFill>
-        <p:spPr>
-          <a:xfrm>
-            <a:off x="6324600" y="2231302"/>
-            <a:ext cx="5242560" cy="1732455"/>
-          </a:xfrm>
-          <a:prstGeom prst="rect">
-            <a:avLst/>
-          </a:prstGeom>
-        </p:spPr>
-      </p:pic>
-      <p:sp>
-        <p:nvSpPr>
-          <p:cNvPr id="15" name="TextBox 14"/>
+      <p:sp>
+        <p:nvSpPr>
+          <p:cNvPr id="20" name="TextBox 19"/>
           <p:cNvSpPr txBox="1"/>
           <p:nvPr/>
         </p:nvSpPr>
         <p:spPr>
           <a:xfrm>
-            <a:off x="685800" y="4198620"/>
-            <a:ext cx="5082540" cy="243840"/>
+            <a:off x="685800" y="5455920"/>
+            <a:ext cx="7940040" cy="243840"/>
           </a:xfrm>
           <a:prstGeom prst="rect">
             <a:avLst/>
@@ -8886,21 +9090,68 @@
               </a:defRPr>
             </a:pPr>
             <a:r>
-              <a:t>1. 방문자별 입력</a:t>
-            </a:r>
-          </a:p>
-        </p:txBody>
-      </p:sp>
-      <p:sp>
-        <p:nvSpPr>
-          <p:cNvPr id="16" name="TextBox 15"/>
+              <a:t>대상 선택 → 발주처 제출 → 승인 결과 확인 → 승인 완료 처리</a:t>
+            </a:r>
+          </a:p>
+        </p:txBody>
+      </p:sp>
+      <p:sp>
+        <p:nvSpPr>
+          <p:cNvPr id="21" name="Rounded Rectangle 20"/>
+          <p:cNvSpPr/>
+          <p:nvPr/>
+        </p:nvSpPr>
+        <p:spPr>
+          <a:xfrm>
+            <a:off x="8869680" y="3832860"/>
+            <a:ext cx="2651760" cy="1752600"/>
+          </a:xfrm>
+          <a:prstGeom prst="roundRect">
+            <a:avLst>
+              <a:gd name="adj" fmla="val 12000"/>
+            </a:avLst>
+          </a:prstGeom>
+          <a:solidFill>
+            <a:srgbClr val="EAF4EE"/>
+          </a:solidFill>
+          <a:ln w="12700">
+            <a:solidFill>
+              <a:srgbClr val="D5E4DD"/>
+            </a:solidFill>
+          </a:ln>
+        </p:spPr>
+        <p:style>
+          <a:lnRef idx="1">
+            <a:schemeClr val="accent1"/>
+          </a:lnRef>
+          <a:fillRef idx="3">
+            <a:schemeClr val="accent1"/>
+          </a:fillRef>
+          <a:effectRef idx="2">
+            <a:schemeClr val="accent1"/>
+          </a:effectRef>
+          <a:fontRef idx="minor">
+            <a:schemeClr val="lt1"/>
+          </a:fontRef>
+        </p:style>
+        <p:txBody>
+          <a:bodyPr rtlCol="0" anchor="ctr"/>
+          <a:lstStyle/>
+          <a:p>
+            <a:pPr algn="ctr"/>
+          </a:p>
+        </p:txBody>
+      </p:sp>
+      <p:sp>
+        <p:nvSpPr>
+          <p:cNvPr id="22" name="TextBox 21"/>
           <p:cNvSpPr txBox="1"/>
           <p:nvPr/>
         </p:nvSpPr>
         <p:spPr>
           <a:xfrm>
-            <a:off x="685800" y="4442460"/>
-            <a:ext cx="5029200" cy="236220"/>
+            <a:off x="9006840" y="3970020"/>
+            <a:ext cx="2346960" cy="266700"/>
           </a:xfrm>
           <a:prstGeom prst="rect">
             <a:avLst/>
@@ -8915,31 +9166,31 @@
           <a:p>
             <a:pPr>
               <a:spcAft>
-                <a:spcPts val="360"/>
+                <a:spcPts val="520"/>
               </a:spcAft>
-              <a:defRPr sz="1080" b="0">
-                <a:solidFill>
-                  <a:srgbClr val="697D82"/>
+              <a:defRPr sz="1560" b="1">
+                <a:solidFill>
+                  <a:srgbClr val="17684F"/>
                 </a:solidFill>
                 <a:latin typeface="Noto Sans CJK KR"/>
               </a:defRPr>
             </a:pPr>
             <a:r>
-              <a:t>방문일자·목적·요청팀·출입위치 개별 지정</a:t>
-            </a:r>
-          </a:p>
-        </p:txBody>
-      </p:sp>
-      <p:sp>
-        <p:nvSpPr>
-          <p:cNvPr id="17" name="TextBox 16"/>
+              <a:t>관리자 전용 처리</a:t>
+            </a:r>
+          </a:p>
+        </p:txBody>
+      </p:sp>
+      <p:sp>
+        <p:nvSpPr>
+          <p:cNvPr id="23" name="TextBox 22"/>
           <p:cNvSpPr txBox="1"/>
           <p:nvPr/>
         </p:nvSpPr>
         <p:spPr>
           <a:xfrm>
-            <a:off x="685800" y="4693920"/>
-            <a:ext cx="5082540" cy="243840"/>
+            <a:off x="9006840" y="4328160"/>
+            <a:ext cx="2316480" cy="1082040"/>
           </a:xfrm>
           <a:prstGeom prst="rect">
             <a:avLst/>
@@ -8954,251 +9205,65 @@
           <a:p>
             <a:pPr>
               <a:spcAft>
-                <a:spcPts val="440"/>
+                <a:spcPts val="420"/>
               </a:spcAft>
-              <a:defRPr sz="1320" b="1">
-                <a:solidFill>
-                  <a:srgbClr val="193B30"/>
+              <a:defRPr sz="1260" b="0">
+                <a:solidFill>
+                  <a:srgbClr val="35464C"/>
                 </a:solidFill>
                 <a:latin typeface="Noto Sans CJK KR"/>
               </a:defRPr>
             </a:pPr>
             <a:r>
-              <a:t>2. 입력 확인 후 신청</a:t>
-            </a:r>
-          </a:p>
-        </p:txBody>
-      </p:sp>
-      <p:sp>
-        <p:nvSpPr>
-          <p:cNvPr id="18" name="TextBox 17"/>
-          <p:cNvSpPr txBox="1"/>
-          <p:nvPr/>
-        </p:nvSpPr>
-        <p:spPr>
-          <a:xfrm>
-            <a:off x="685800" y="4937760"/>
-            <a:ext cx="5029200" cy="236220"/>
-          </a:xfrm>
-          <a:prstGeom prst="rect">
-            <a:avLst/>
-          </a:prstGeom>
-          <a:noFill/>
-        </p:spPr>
-        <p:txBody>
-          <a:bodyPr wrap="square" lIns="0" rIns="0" tIns="0" bIns="0">
-            <a:spAutoFit/>
-          </a:bodyPr>
-          <a:lstStyle/>
+              <a:t>• 최대 10명 일괄 선택</a:t>
+            </a:r>
+          </a:p>
           <a:p>
             <a:pPr>
               <a:spcAft>
-                <a:spcPts val="360"/>
+                <a:spcPts val="420"/>
               </a:spcAft>
-              <a:defRPr sz="1080" b="0">
-                <a:solidFill>
-                  <a:srgbClr val="697D82"/>
+              <a:defRPr sz="1260" b="0">
+                <a:solidFill>
+                  <a:srgbClr val="35464C"/>
                 </a:solidFill>
                 <a:latin typeface="Noto Sans CJK KR"/>
               </a:defRPr>
             </a:pPr>
             <a:r>
-              <a:t>자동 형식 적용·오류 안내·탭 자동 임시저장</a:t>
-            </a:r>
-          </a:p>
-        </p:txBody>
-      </p:sp>
-      <p:sp>
-        <p:nvSpPr>
-          <p:cNvPr id="19" name="TextBox 18"/>
-          <p:cNvSpPr txBox="1"/>
-          <p:nvPr/>
-        </p:nvSpPr>
-        <p:spPr>
-          <a:xfrm>
-            <a:off x="685800" y="5189220"/>
-            <a:ext cx="5082540" cy="243840"/>
-          </a:xfrm>
-          <a:prstGeom prst="rect">
-            <a:avLst/>
-          </a:prstGeom>
-          <a:noFill/>
-        </p:spPr>
-        <p:txBody>
-          <a:bodyPr wrap="square" lIns="0" rIns="0" tIns="0" bIns="0">
-            <a:spAutoFit/>
-          </a:bodyPr>
-          <a:lstStyle/>
+              <a:t>• 발주처 제출·승인·삭제</a:t>
+            </a:r>
+          </a:p>
           <a:p>
             <a:pPr>
               <a:spcAft>
-                <a:spcPts val="440"/>
+                <a:spcPts val="420"/>
               </a:spcAft>
-              <a:defRPr sz="1320" b="1">
-                <a:solidFill>
-                  <a:srgbClr val="193B30"/>
+              <a:defRPr sz="1260" b="0">
+                <a:solidFill>
+                  <a:srgbClr val="35464C"/>
                 </a:solidFill>
                 <a:latin typeface="Noto Sans CJK KR"/>
               </a:defRPr>
             </a:pPr>
             <a:r>
-              <a:t>3. 신청 목록 확인</a:t>
-            </a:r>
-          </a:p>
-        </p:txBody>
-      </p:sp>
-      <p:sp>
-        <p:nvSpPr>
-          <p:cNvPr id="20" name="TextBox 19"/>
-          <p:cNvSpPr txBox="1"/>
-          <p:nvPr/>
-        </p:nvSpPr>
-        <p:spPr>
-          <a:xfrm>
-            <a:off x="685800" y="5433060"/>
-            <a:ext cx="5029200" cy="236220"/>
-          </a:xfrm>
-          <a:prstGeom prst="rect">
-            <a:avLst/>
-          </a:prstGeom>
-          <a:noFill/>
-        </p:spPr>
-        <p:txBody>
-          <a:bodyPr wrap="square" lIns="0" rIns="0" tIns="0" bIns="0">
-            <a:spAutoFit/>
-          </a:bodyPr>
-          <a:lstStyle/>
+              <a:t>• 목록 안에서 바로 수정</a:t>
+            </a:r>
+          </a:p>
           <a:p>
             <a:pPr>
               <a:spcAft>
-                <a:spcPts val="360"/>
+                <a:spcPts val="420"/>
               </a:spcAft>
-              <a:defRPr sz="1080" b="0">
-                <a:solidFill>
-                  <a:srgbClr val="697D82"/>
+              <a:defRPr sz="1260" b="0">
+                <a:solidFill>
+                  <a:srgbClr val="35464C"/>
                 </a:solidFill>
                 <a:latin typeface="Noto Sans CJK KR"/>
               </a:defRPr>
             </a:pPr>
             <a:r>
-              <a:t>신청 후 목록 표시 / 개인정보는 관리자 전용</a:t>
-            </a:r>
-          </a:p>
-        </p:txBody>
-      </p:sp>
-      <p:sp>
-        <p:nvSpPr>
-          <p:cNvPr id="21" name="TextBox 20"/>
-          <p:cNvSpPr txBox="1"/>
-          <p:nvPr/>
-        </p:nvSpPr>
-        <p:spPr>
-          <a:xfrm>
-            <a:off x="6385560" y="4198620"/>
-            <a:ext cx="5082540" cy="243840"/>
-          </a:xfrm>
-          <a:prstGeom prst="rect">
-            <a:avLst/>
-          </a:prstGeom>
-          <a:noFill/>
-        </p:spPr>
-        <p:txBody>
-          <a:bodyPr wrap="square" lIns="0" rIns="0" tIns="0" bIns="0">
-            <a:spAutoFit/>
-          </a:bodyPr>
-          <a:lstStyle/>
-          <a:p>
-            <a:pPr>
-              <a:spcAft>
-                <a:spcPts val="440"/>
-              </a:spcAft>
-              <a:defRPr sz="1320" b="1">
-                <a:solidFill>
-                  <a:srgbClr val="193B30"/>
-                </a:solidFill>
-                <a:latin typeface="Noto Sans CJK KR"/>
-              </a:defRPr>
-            </a:pPr>
-            <a:r>
-              <a:t>1. 관리자 접속 후 확인·수정</a:t>
-            </a:r>
-          </a:p>
-        </p:txBody>
-      </p:sp>
-      <p:sp>
-        <p:nvSpPr>
-          <p:cNvPr id="22" name="TextBox 21"/>
-          <p:cNvSpPr txBox="1"/>
-          <p:nvPr/>
-        </p:nvSpPr>
-        <p:spPr>
-          <a:xfrm>
-            <a:off x="6385560" y="4442460"/>
-            <a:ext cx="5029200" cy="236220"/>
-          </a:xfrm>
-          <a:prstGeom prst="rect">
-            <a:avLst/>
-          </a:prstGeom>
-          <a:noFill/>
-        </p:spPr>
-        <p:txBody>
-          <a:bodyPr wrap="square" lIns="0" rIns="0" tIns="0" bIns="0">
-            <a:spAutoFit/>
-          </a:bodyPr>
-          <a:lstStyle/>
-          <a:p>
-            <a:pPr>
-              <a:spcAft>
-                <a:spcPts val="360"/>
-              </a:spcAft>
-              <a:defRPr sz="1080" b="0">
-                <a:solidFill>
-                  <a:srgbClr val="697D82"/>
-                </a:solidFill>
-                <a:latin typeface="Noto Sans CJK KR"/>
-              </a:defRPr>
-            </a:pPr>
-            <a:r>
-              <a:t>같은 화면의 목록에서 바로 수정·저장</a:t>
-            </a:r>
-          </a:p>
-        </p:txBody>
-      </p:sp>
-      <p:sp>
-        <p:nvSpPr>
-          <p:cNvPr id="23" name="TextBox 22"/>
-          <p:cNvSpPr txBox="1"/>
-          <p:nvPr/>
-        </p:nvSpPr>
-        <p:spPr>
-          <a:xfrm>
-            <a:off x="6385560" y="4693920"/>
-            <a:ext cx="5082540" cy="243840"/>
-          </a:xfrm>
-          <a:prstGeom prst="rect">
-            <a:avLst/>
-          </a:prstGeom>
-          <a:noFill/>
-        </p:spPr>
-        <p:txBody>
-          <a:bodyPr wrap="square" lIns="0" rIns="0" tIns="0" bIns="0">
-            <a:spAutoFit/>
-          </a:bodyPr>
-          <a:lstStyle/>
-          <a:p>
-            <a:pPr>
-              <a:spcAft>
-                <a:spcPts val="440"/>
-              </a:spcAft>
-              <a:defRPr sz="1320" b="1">
-                <a:solidFill>
-                  <a:srgbClr val="193B30"/>
-                </a:solidFill>
-                <a:latin typeface="Noto Sans CJK KR"/>
-              </a:defRPr>
-            </a:pPr>
-            <a:r>
-              <a:t>2. 최대 10명 선택·발주처 제출</a:t>
+              <a:t>• 조회 내역 CSV 다운로드</a:t>
             </a:r>
           </a:p>
         </p:txBody>
@@ -9211,125 +9276,8 @@
         </p:nvSpPr>
         <p:spPr>
           <a:xfrm>
-            <a:off x="6385560" y="4937760"/>
-            <a:ext cx="5029200" cy="236220"/>
-          </a:xfrm>
-          <a:prstGeom prst="rect">
-            <a:avLst/>
-          </a:prstGeom>
-          <a:noFill/>
-        </p:spPr>
-        <p:txBody>
-          <a:bodyPr wrap="square" lIns="0" rIns="0" tIns="0" bIns="0">
-            <a:spAutoFit/>
-          </a:bodyPr>
-          <a:lstStyle/>
-          <a:p>
-            <a:pPr>
-              <a:spcAft>
-                <a:spcPts val="360"/>
-              </a:spcAft>
-              <a:defRPr sz="1080" b="0">
-                <a:solidFill>
-                  <a:srgbClr val="697D82"/>
-                </a:solidFill>
-                <a:latin typeface="Noto Sans CJK KR"/>
-              </a:defRPr>
-            </a:pPr>
-            <a:r>
-              <a:t>메일 앱에서 실제 전송 후 전달 완료 기록</a:t>
-            </a:r>
-          </a:p>
-        </p:txBody>
-      </p:sp>
-      <p:sp>
-        <p:nvSpPr>
-          <p:cNvPr id="25" name="TextBox 24"/>
-          <p:cNvSpPr txBox="1"/>
-          <p:nvPr/>
-        </p:nvSpPr>
-        <p:spPr>
-          <a:xfrm>
-            <a:off x="6385560" y="5189220"/>
-            <a:ext cx="5082540" cy="243840"/>
-          </a:xfrm>
-          <a:prstGeom prst="rect">
-            <a:avLst/>
-          </a:prstGeom>
-          <a:noFill/>
-        </p:spPr>
-        <p:txBody>
-          <a:bodyPr wrap="square" lIns="0" rIns="0" tIns="0" bIns="0">
-            <a:spAutoFit/>
-          </a:bodyPr>
-          <a:lstStyle/>
-          <a:p>
-            <a:pPr>
-              <a:spcAft>
-                <a:spcPts val="440"/>
-              </a:spcAft>
-              <a:defRPr sz="1320" b="1">
-                <a:solidFill>
-                  <a:srgbClr val="193B30"/>
-                </a:solidFill>
-                <a:latin typeface="Noto Sans CJK KR"/>
-              </a:defRPr>
-            </a:pPr>
-            <a:r>
-              <a:t>3. 승인 결과 확인 후 처리</a:t>
-            </a:r>
-          </a:p>
-        </p:txBody>
-      </p:sp>
-      <p:sp>
-        <p:nvSpPr>
-          <p:cNvPr id="26" name="TextBox 25"/>
-          <p:cNvSpPr txBox="1"/>
-          <p:nvPr/>
-        </p:nvSpPr>
-        <p:spPr>
-          <a:xfrm>
-            <a:off x="6385560" y="5433060"/>
-            <a:ext cx="5029200" cy="236220"/>
-          </a:xfrm>
-          <a:prstGeom prst="rect">
-            <a:avLst/>
-          </a:prstGeom>
-          <a:noFill/>
-        </p:spPr>
-        <p:txBody>
-          <a:bodyPr wrap="square" lIns="0" rIns="0" tIns="0" bIns="0">
-            <a:spAutoFit/>
-          </a:bodyPr>
-          <a:lstStyle/>
-          <a:p>
-            <a:pPr>
-              <a:spcAft>
-                <a:spcPts val="360"/>
-              </a:spcAft>
-              <a:defRPr sz="1080" b="0">
-                <a:solidFill>
-                  <a:srgbClr val="697D82"/>
-                </a:solidFill>
-                <a:latin typeface="Noto Sans CJK KR"/>
-              </a:defRPr>
-            </a:pPr>
-            <a:r>
-              <a:t>승인 완료 처리·선택 삭제·CSV 다운로드</a:t>
-            </a:r>
-          </a:p>
-        </p:txBody>
-      </p:sp>
-      <p:sp>
-        <p:nvSpPr>
-          <p:cNvPr id="27" name="TextBox 26"/>
-          <p:cNvSpPr txBox="1"/>
-          <p:nvPr/>
-        </p:nvSpPr>
-        <p:spPr>
-          <a:xfrm>
-            <a:off x="655320" y="5722620"/>
-            <a:ext cx="10744200" cy="228600"/>
+            <a:off x="655320" y="5844540"/>
+            <a:ext cx="10728960" cy="205740"/>
           </a:xfrm>
           <a:prstGeom prst="rect">
             <a:avLst/>
@@ -9354,14 +9302,14 @@
               </a:defRPr>
             </a:pPr>
             <a:r>
-              <a:t>화면: 현재 구현 UI를 가상 방문자 1명으로 재현 · 운영 데이터 변경 없음 · 효과는 정량 측정 전 기대 효과</a:t>
-            </a:r>
-          </a:p>
-        </p:txBody>
-      </p:sp>
-      <p:sp>
-        <p:nvSpPr>
-          <p:cNvPr id="28" name="Rounded Rectangle 27"/>
+              <a:t>현재 구현 UI를 가상 방문자로 재현 · 핵심 영역 확대 및 대비 보정 · 운영 데이터 변경 없음</a:t>
+            </a:r>
+          </a:p>
+        </p:txBody>
+      </p:sp>
+      <p:sp>
+        <p:nvSpPr>
+          <p:cNvPr id="25" name="Rounded Rectangle 24"/>
           <p:cNvSpPr/>
           <p:nvPr/>
         </p:nvSpPr>
@@ -9406,7 +9354,7 @@
       </p:sp>
       <p:sp>
         <p:nvSpPr>
-          <p:cNvPr id="29" name="TextBox 28"/>
+          <p:cNvPr id="26" name="TextBox 25"/>
           <p:cNvSpPr txBox="1"/>
           <p:nvPr/>
         </p:nvSpPr>
@@ -9438,7 +9386,7 @@
               </a:defRPr>
             </a:pPr>
             <a:r>
-              <a:t>기대 효과: 반복 확인 감소 · 입력 누락 예방 · 신청 내역 공유 · 관리자 처리 절차 간소화</a:t>
+              <a:t>신청자는 입력과 신청에 집중하고, 관리자는 같은 목록에서 확인·제출·승인까지 처리</a:t>
             </a:r>
           </a:p>
         </p:txBody>

</xml_diff>